<commit_message>
modifica aggiunta logo unipv
</commit_message>
<xml_diff>
--- a/docs/PRESENTAZIONE/BarberShop Management Presentazione.pptx
+++ b/docs/PRESENTAZIONE/BarberShop Management Presentazione.pptx
@@ -27,14 +27,14 @@
   <p:notesSz cx="6858000" cy="9144000"/>
   <p:embeddedFontLst>
     <p:embeddedFont>
-      <p:font typeface="DM Sans" pitchFamily="2" charset="77"/>
+      <p:font typeface="DM Sans" pitchFamily="2" charset="0"/>
       <p:regular r:id="rId17"/>
       <p:bold r:id="rId18"/>
       <p:italic r:id="rId19"/>
       <p:boldItalic r:id="rId20"/>
     </p:embeddedFont>
     <p:embeddedFont>
-      <p:font typeface="Merriweather" pitchFamily="2" charset="77"/>
+      <p:font typeface="Merriweather" panose="00000500000000000000" pitchFamily="2" charset="0"/>
       <p:regular r:id="rId21"/>
       <p:bold r:id="rId22"/>
       <p:italic r:id="rId23"/>
@@ -11527,6 +11527,36 @@
           </a:p>
         </p:txBody>
       </p:sp>
+      <p:pic>
+        <p:nvPicPr>
+          <p:cNvPr id="3" name="Immagine 2">
+            <a:extLst>
+              <a:ext uri="{FF2B5EF4-FFF2-40B4-BE49-F238E27FC236}">
+                <a16:creationId xmlns:a16="http://schemas.microsoft.com/office/drawing/2014/main" id="{B4E5540E-DF09-6AFF-84F0-C76C1376C1B1}"/>
+              </a:ext>
+            </a:extLst>
+          </p:cNvPr>
+          <p:cNvPicPr>
+            <a:picLocks noChangeAspect="1"/>
+          </p:cNvPicPr>
+          <p:nvPr/>
+        </p:nvPicPr>
+        <p:blipFill>
+          <a:blip r:embed="rId4"/>
+          <a:stretch>
+            <a:fillRect/>
+          </a:stretch>
+        </p:blipFill>
+        <p:spPr>
+          <a:xfrm>
+            <a:off x="0" y="0"/>
+            <a:ext cx="1371719" cy="1295512"/>
+          </a:xfrm>
+          <a:prstGeom prst="rect">
+            <a:avLst/>
+          </a:prstGeom>
+        </p:spPr>
+      </p:pic>
     </p:spTree>
   </p:cSld>
   <p:clrMapOvr>
@@ -16332,6 +16362,77 @@
           </a:p>
         </p:txBody>
       </p:sp>
+      <p:sp>
+        <p:nvSpPr>
+          <p:cNvPr id="2" name="CasellaDiTesto 1">
+            <a:extLst>
+              <a:ext uri="{FF2B5EF4-FFF2-40B4-BE49-F238E27FC236}">
+                <a16:creationId xmlns:a16="http://schemas.microsoft.com/office/drawing/2014/main" id="{A7B9CC22-E1D3-7797-F600-0B30858A2592}"/>
+              </a:ext>
+            </a:extLst>
+          </p:cNvPr>
+          <p:cNvSpPr txBox="1"/>
+          <p:nvPr/>
+        </p:nvSpPr>
+        <p:spPr>
+          <a:xfrm>
+            <a:off x="10422193" y="6168420"/>
+            <a:ext cx="1611261" cy="523220"/>
+          </a:xfrm>
+          <a:prstGeom prst="rect">
+            <a:avLst/>
+          </a:prstGeom>
+          <a:noFill/>
+        </p:spPr>
+        <p:txBody>
+          <a:bodyPr wrap="square" rtlCol="0">
+            <a:spAutoFit/>
+          </a:bodyPr>
+          <a:lstStyle/>
+          <a:p>
+            <a:r>
+              <a:rPr lang="it-IT" dirty="0"/>
+              <a:t>Andrea Caminiti</a:t>
+            </a:r>
+          </a:p>
+          <a:p>
+            <a:r>
+              <a:rPr lang="it-IT" dirty="0"/>
+              <a:t>Fabio Fiducioso</a:t>
+            </a:r>
+          </a:p>
+        </p:txBody>
+      </p:sp>
+      <p:pic>
+        <p:nvPicPr>
+          <p:cNvPr id="4" name="Immagine 3">
+            <a:extLst>
+              <a:ext uri="{FF2B5EF4-FFF2-40B4-BE49-F238E27FC236}">
+                <a16:creationId xmlns:a16="http://schemas.microsoft.com/office/drawing/2014/main" id="{0A586400-ADBF-6122-EA1D-782512E91394}"/>
+              </a:ext>
+            </a:extLst>
+          </p:cNvPr>
+          <p:cNvPicPr>
+            <a:picLocks noChangeAspect="1"/>
+          </p:cNvPicPr>
+          <p:nvPr/>
+        </p:nvPicPr>
+        <p:blipFill>
+          <a:blip r:embed="rId5"/>
+          <a:stretch>
+            <a:fillRect/>
+          </a:stretch>
+        </p:blipFill>
+        <p:spPr>
+          <a:xfrm>
+            <a:off x="0" y="-1"/>
+            <a:ext cx="1371719" cy="1295512"/>
+          </a:xfrm>
+          <a:prstGeom prst="rect">
+            <a:avLst/>
+          </a:prstGeom>
+        </p:spPr>
+      </p:pic>
     </p:spTree>
   </p:cSld>
   <p:clrMapOvr>

</xml_diff>